<commit_message>
New flagship bank PHY2-DC-SPRTC3-10292026 (3 steps, 5-6 resistors, five options); all docs regenerated
Co-Authored-By: Claude Fable 5.1 <noreply@anthropic.com>
</commit_message>
<xml_diff>
--- a/docs/How-the-circuit-bank-works.pptx
+++ b/docs/How-the-circuit-bank-works.pptx
@@ -118,7 +118,7 @@
   <p:extLst>
     <p:ext uri="{521415D9-36F7-43E2-AB2F-B90AF26B5E84}">
       <p14:sectionLst xmlns:p14="http://schemas.microsoft.com/office/powerpoint/2010/main">
-        <p14:section name="How the circuit bank works" id="{0048d788-d1cb-6c9c-8f9d-37213e439c57}">
+        <p14:section name="How the circuit bank works" id="{8a529e8e-9910-5f14-6cc7-7a458687f61e}">
           <p14:sldIdLst>
             <p14:sldId id="256"/>
             <p14:sldId id="257"/>
@@ -963,7 +963,7 @@
           <a:p>
             <a:r>
               <a:rPr lang="en-US" dirty="0"/>
-              <a:t>The counts come from enumerating series-parallel trees with alternating series/parallel nodes. At exactly three steps with four to six resistors there are 34 shapes; the 30-item bank uses 30 of them. The first bank mixed 2 to 5 steps — structurally isomorphic, but not fair as a random draw.</a:t>
+              <a:t>The counts come from enumerating series-parallel trees with alternating series/parallel nodes. At exactly three steps there are 34 shapes with four to six resistors and exactly 30 with five to six; the bank uses every one of those 30, so the arithmetic load is also held in a narrow band. The first bank mixed 2 to 5 steps — structurally isomorphic, but not fair as a random draw.</a:t>
             </a:r>
             <a:endParaRPr lang="en-US" dirty="0"/>
           </a:p>
@@ -1843,7 +1843,7 @@
           <a:p>
             <a:r>
               <a:rPr lang="en-US" dirty="0"/>
-              <a:t>When the LLM proposer is used, correctness is unchanged — the critic and the engine do not care who wrote the string — but the set of shapes differs from run to run and completeness is not assured. That mattered once we fixed one difficulty: finding 30 of 34 shapes is a job for enumeration.</a:t>
+              <a:t>When the LLM proposer is used, correctness is unchanged — the critic and the engine do not care who wrote the string — but the set of shapes differs from run to run and completeness is not assured. That mattered once we fixed one difficulty: finding all 30 shapes is a job for enumeration.</a:t>
             </a:r>
             <a:endParaRPr lang="en-US" dirty="0"/>
           </a:p>
@@ -2730,7 +2730,7 @@
       </p:sp>
       <p:sp>
         <p:nvSpPr>
-          <p:cNvPr id="5" name="stat 34"/>
+          <p:cNvPr id="5" name="stat 30"/>
           <p:cNvSpPr txBox="1"/>
           <p:nvPr/>
         </p:nvSpPr>
@@ -2758,7 +2758,7 @@
                   <a:schemeClr val="accent1"/>
                 </a:solidFill>
               </a:rPr>
-              <a:t>34</a:t>
+              <a:t>30</a:t>
             </a:r>
             <a:endParaRPr lang="en-US" sz="4800" dirty="0"/>
           </a:p>
@@ -2794,7 +2794,7 @@
                   <a:schemeClr val="tx1"/>
                 </a:solidFill>
               </a:rPr>
-              <a:t>distinct shapes at exactly 3 steps — so a one-difficulty bank of 30 uses 30 of them</a:t>
+              <a:t>distinct 3-step shapes with 5–6 resistors (34 with 4–6). The bank uses every one of the 30</a:t>
             </a:r>
             <a:endParaRPr lang="en-US" sz="1250" dirty="0"/>
           </a:p>
@@ -3082,7 +3082,7 @@
                   <a:schemeClr val="tx2"/>
                 </a:solidFill>
               </a:rPr>
-              <a:t>an LLM finding 30 of 34 within 5 passes is unlikely; the enumerator lists all 34</a:t>
+              <a:t>an LLM finding all 30 within 5 passes is unlikely; the enumerator lists every one</a:t>
             </a:r>
             <a:endParaRPr lang="en-US" sz="1150" dirty="0"/>
           </a:p>
@@ -3498,7 +3498,7 @@
                 <a:ea typeface="Courier New" pitchFamily="34" charset="-122"/>
                 <a:cs typeface="Courier New" pitchFamily="34" charset="-120"/>
               </a:rPr>
-              <a:t>PHY2-DC-SPRTC3-10232026</a:t>
+              <a:t>PHY2-DC-SPRTC3-10292026</a:t>
             </a:r>
             <a:endParaRPr lang="en-US" sz="1500" dirty="0"/>
           </a:p>
@@ -3573,7 +3573,7 @@
                   <a:schemeClr val="tx1"/>
                 </a:solidFill>
               </a:rPr>
-              <a:t>one difficulty: exactly 3 steps, 4–6 resistors</a:t>
+              <a:t>one difficulty: exactly 3 steps, 5–6 resistors</a:t>
             </a:r>
             <a:endParaRPr lang="en-US" sz="1150" dirty="0"/>
           </a:p>
@@ -3607,7 +3607,7 @@
                   <a:schemeClr val="tx1"/>
                 </a:solidFill>
               </a:rPr>
-              <a:t>0 rejections — 30 of the 34 shapes</a:t>
+              <a:t>0 rejections — all 30 shapes</a:t>
             </a:r>
             <a:endParaRPr lang="en-US" sz="1150" dirty="0"/>
           </a:p>
@@ -3659,7 +3659,7 @@
       </p:sp>
       <p:pic>
         <p:nvPicPr>
-          <p:cNvPr id="14" name="bank figure 2" descr="/Users/myrlaphillippe/Downloads/circuit-bank/circuit-banks/PHY II Electricity and Magnetism/1_DC Circuits/PHY2-DC-SPRTC3-10232026/figures/q2.png">    </p:cNvPr>
+          <p:cNvPr id="14" name="bank figure 2" descr="/Users/myrlaphillippe/Downloads/circuit-bank/circuit-banks/PHY II Electricity and Magnetism/1_DC Circuits/PHY2-DC-SPRTC3-10292026/figures/q4.png">    </p:cNvPr>
           <p:cNvPicPr>
             <a:picLocks noChangeAspect="1"/>
           </p:cNvPicPr>
@@ -6421,7 +6421,7 @@
                   <a:schemeClr val="tx2"/>
                 </a:solidFill>
               </a:rPr>
-              <a:t>Your drawn problem takes the same number of steps as your neighbour's.</a:t>
+              <a:t>Your drawn problem takes the same number of steps (3) with the same number of resistors (5–6) as your neighbour's.</a:t>
             </a:r>
             <a:endParaRPr lang="en-US" sz="1150" dirty="0"/>
           </a:p>
@@ -6482,7 +6482,7 @@
                   <a:schemeClr val="tx2"/>
                 </a:solidFill>
               </a:rPr>
-              <a:t>reduction_steps: 3 — the critic rejects any other count</a:t>
+              <a:t>reduction_steps: 3, resistors 5–6 — the critic rejects anything else</a:t>
             </a:r>
             <a:endParaRPr lang="en-US" sz="1150" dirty="0"/>
           </a:p>
@@ -6787,7 +6787,7 @@
                   <a:schemeClr val="tx2"/>
                 </a:solidFill>
               </a:rPr>
-              <a:t>Each distractor is the number one specific error produces.</a:t>
+              <a:t>Three options are the numbers one specific error each produces; a fifth sits near the largest so a lone big value is no giveaway.</a:t>
             </a:r>
             <a:endParaRPr lang="en-US" sz="1150" dirty="0"/>
           </a:p>
@@ -6848,7 +6848,7 @@
                   <a:schemeClr val="tx2"/>
                 </a:solidFill>
               </a:rPr>
-              <a:t>distractors.py re-solves the circuit as a mistaken student would</a:t>
+              <a:t>distractors.py re-solves the circuit as a mistaken student would, then adds a decoy near the largest</a:t>
             </a:r>
             <a:endParaRPr lang="en-US" sz="1150" dirty="0"/>
           </a:p>
@@ -7789,11 +7789,11 @@
         <p:spPr>
           <a:xfrm>
             <a:off x="5760720" y="1371600"/>
-            <a:ext cx="5852160" cy="896112"/>
+            <a:ext cx="5852160" cy="749808"/>
           </a:xfrm>
           <a:prstGeom prst="roundRect">
             <a:avLst>
-              <a:gd name="adj" fmla="val 8163"/>
+              <a:gd name="adj" fmla="val 9756"/>
             </a:avLst>
           </a:prstGeom>
           <a:solidFill>
@@ -7815,8 +7815,8 @@
         </p:nvSpPr>
         <p:spPr>
           <a:xfrm>
-            <a:off x="5897880" y="1444752"/>
-            <a:ext cx="1371600" cy="749808"/>
+            <a:off x="5897880" y="1426464"/>
+            <a:ext cx="1371600" cy="640080"/>
           </a:xfrm>
           <a:prstGeom prst="rect">
             <a:avLst/>
@@ -7832,7 +7832,7 @@
               <a:buNone/>
             </a:pPr>
             <a:r>
-              <a:rPr lang="en-US" sz="2200" b="1" dirty="0">
+              <a:rPr lang="en-US" sz="2000" b="1" dirty="0">
                 <a:solidFill>
                   <a:schemeClr val="tx1"/>
                 </a:solidFill>
@@ -7842,7 +7842,7 @@
               </a:rPr>
               <a:t>0.92 A</a:t>
             </a:r>
-            <a:endParaRPr lang="en-US" sz="2200" dirty="0"/>
+            <a:endParaRPr lang="en-US" sz="2000" dirty="0"/>
           </a:p>
         </p:txBody>
       </p:sp>
@@ -7854,8 +7854,8 @@
         </p:nvSpPr>
         <p:spPr>
           <a:xfrm>
-            <a:off x="7315200" y="1444752"/>
-            <a:ext cx="4206240" cy="749808"/>
+            <a:off x="7315200" y="1426464"/>
+            <a:ext cx="4206240" cy="640080"/>
           </a:xfrm>
           <a:prstGeom prst="rect">
             <a:avLst/>
@@ -7871,7 +7871,7 @@
               <a:buNone/>
             </a:pPr>
             <a:r>
-              <a:rPr lang="en-US" sz="1150" b="1" dirty="0">
+              <a:rPr lang="en-US" sz="1100" b="1" dirty="0">
                 <a:solidFill>
                   <a:schemeClr val="tx1"/>
                 </a:solidFill>
@@ -7881,21 +7881,21 @@
               </a:rPr>
               <a:t>all_series</a:t>
             </a:r>
-            <a:endParaRPr lang="en-US" sz="1150" dirty="0"/>
-          </a:p>
-          <a:p>
-            <a:pPr indent="0" marL="0">
-              <a:buNone/>
-            </a:pPr>
-            <a:r>
-              <a:rPr lang="en-US" sz="1150" dirty="0">
+            <a:endParaRPr lang="en-US" sz="1100" dirty="0"/>
+          </a:p>
+          <a:p>
+            <a:pPr indent="0" marL="0">
+              <a:buNone/>
+            </a:pPr>
+            <a:r>
+              <a:rPr lang="en-US" sz="1100" dirty="0">
                 <a:solidFill>
                   <a:schemeClr val="tx2"/>
                 </a:solidFill>
               </a:rPr>
               <a:t>adds every resistor as if in series: 12 / (3 + 6 + 4)</a:t>
             </a:r>
-            <a:endParaRPr lang="en-US" sz="1150" dirty="0"/>
+            <a:endParaRPr lang="en-US" sz="1100" dirty="0"/>
           </a:p>
         </p:txBody>
       </p:sp>
@@ -7907,12 +7907,12 @@
         </p:nvSpPr>
         <p:spPr>
           <a:xfrm>
-            <a:off x="5760720" y="2395728"/>
-            <a:ext cx="5852160" cy="896112"/>
+            <a:off x="5760720" y="2212848"/>
+            <a:ext cx="5852160" cy="749808"/>
           </a:xfrm>
           <a:prstGeom prst="roundRect">
             <a:avLst>
-              <a:gd name="adj" fmla="val 8163"/>
+              <a:gd name="adj" fmla="val 9756"/>
             </a:avLst>
           </a:prstGeom>
           <a:solidFill>
@@ -7934,8 +7934,8 @@
         </p:nvSpPr>
         <p:spPr>
           <a:xfrm>
-            <a:off x="5897880" y="2468880"/>
-            <a:ext cx="1371600" cy="749808"/>
+            <a:off x="5897880" y="2267712"/>
+            <a:ext cx="1371600" cy="640080"/>
           </a:xfrm>
           <a:prstGeom prst="rect">
             <a:avLst/>
@@ -7951,7 +7951,7 @@
               <a:buNone/>
             </a:pPr>
             <a:r>
-              <a:rPr lang="en-US" sz="2200" b="1" dirty="0">
+              <a:rPr lang="en-US" sz="2000" b="1" dirty="0">
                 <a:solidFill>
                   <a:schemeClr val="tx1"/>
                 </a:solidFill>
@@ -7961,7 +7961,7 @@
               </a:rPr>
               <a:t>2.67 A</a:t>
             </a:r>
-            <a:endParaRPr lang="en-US" sz="2200" dirty="0"/>
+            <a:endParaRPr lang="en-US" sz="2000" dirty="0"/>
           </a:p>
         </p:txBody>
       </p:sp>
@@ -7973,8 +7973,8 @@
         </p:nvSpPr>
         <p:spPr>
           <a:xfrm>
-            <a:off x="7315200" y="2468880"/>
-            <a:ext cx="4206240" cy="749808"/>
+            <a:off x="7315200" y="2267712"/>
+            <a:ext cx="4206240" cy="640080"/>
           </a:xfrm>
           <a:prstGeom prst="rect">
             <a:avLst/>
@@ -7990,7 +7990,7 @@
               <a:buNone/>
             </a:pPr>
             <a:r>
-              <a:rPr lang="en-US" sz="1150" b="1" dirty="0">
+              <a:rPr lang="en-US" sz="1100" b="1" dirty="0">
                 <a:solidFill>
                   <a:schemeClr val="tx1"/>
                 </a:solidFill>
@@ -8000,21 +8000,21 @@
               </a:rPr>
               <a:t>no_invert</a:t>
             </a:r>
-            <a:endParaRPr lang="en-US" sz="1150" dirty="0"/>
-          </a:p>
-          <a:p>
-            <a:pPr indent="0" marL="0">
-              <a:buNone/>
-            </a:pPr>
-            <a:r>
-              <a:rPr lang="en-US" sz="1150" dirty="0">
+            <a:endParaRPr lang="en-US" sz="1100" dirty="0"/>
+          </a:p>
+          <a:p>
+            <a:pPr indent="0" marL="0">
+              <a:buNone/>
+            </a:pPr>
+            <a:r>
+              <a:rPr lang="en-US" sz="1100" dirty="0">
                 <a:solidFill>
                   <a:schemeClr val="tx2"/>
                 </a:solidFill>
               </a:rPr>
               <a:t>sums the reciprocals of the parallel pair but forgets to invert: 1/3 + 1/6 = 0.5 “Ω”</a:t>
             </a:r>
-            <a:endParaRPr lang="en-US" sz="1150" dirty="0"/>
+            <a:endParaRPr lang="en-US" sz="1100" dirty="0"/>
           </a:p>
         </p:txBody>
       </p:sp>
@@ -8026,12 +8026,12 @@
         </p:nvSpPr>
         <p:spPr>
           <a:xfrm>
-            <a:off x="5760720" y="3419856"/>
-            <a:ext cx="5852160" cy="896112"/>
+            <a:off x="5760720" y="3054096"/>
+            <a:ext cx="5852160" cy="749808"/>
           </a:xfrm>
           <a:prstGeom prst="roundRect">
             <a:avLst>
-              <a:gd name="adj" fmla="val 8163"/>
+              <a:gd name="adj" fmla="val 9756"/>
             </a:avLst>
           </a:prstGeom>
           <a:solidFill>
@@ -8053,8 +8053,8 @@
         </p:nvSpPr>
         <p:spPr>
           <a:xfrm>
-            <a:off x="5897880" y="3493008"/>
-            <a:ext cx="1371600" cy="749808"/>
+            <a:off x="5897880" y="3108960"/>
+            <a:ext cx="1371600" cy="640080"/>
           </a:xfrm>
           <a:prstGeom prst="rect">
             <a:avLst/>
@@ -8070,7 +8070,7 @@
               <a:buNone/>
             </a:pPr>
             <a:r>
-              <a:rPr lang="en-US" sz="2200" b="1" dirty="0">
+              <a:rPr lang="en-US" sz="2000" b="1" dirty="0">
                 <a:solidFill>
                   <a:schemeClr val="tx1"/>
                 </a:solidFill>
@@ -8080,7 +8080,7 @@
               </a:rPr>
               <a:t>1.33 A</a:t>
             </a:r>
-            <a:endParaRPr lang="en-US" sz="2200" dirty="0"/>
+            <a:endParaRPr lang="en-US" sz="2000" dirty="0"/>
           </a:p>
         </p:txBody>
       </p:sp>
@@ -8092,8 +8092,8 @@
         </p:nvSpPr>
         <p:spPr>
           <a:xfrm>
-            <a:off x="7315200" y="3493008"/>
-            <a:ext cx="4206240" cy="749808"/>
+            <a:off x="7315200" y="3108960"/>
+            <a:ext cx="4206240" cy="640080"/>
           </a:xfrm>
           <a:prstGeom prst="rect">
             <a:avLst/>
@@ -8109,7 +8109,7 @@
               <a:buNone/>
             </a:pPr>
             <a:r>
-              <a:rPr lang="en-US" sz="1150" b="1" dirty="0">
+              <a:rPr lang="en-US" sz="1100" b="1" dirty="0">
                 <a:solidFill>
                   <a:schemeClr val="tx1"/>
                 </a:solidFill>
@@ -8119,21 +8119,21 @@
               </a:rPr>
               <a:t>branch_current</a:t>
             </a:r>
-            <a:endParaRPr lang="en-US" sz="1150" dirty="0"/>
-          </a:p>
-          <a:p>
-            <a:pPr indent="0" marL="0">
-              <a:buNone/>
-            </a:pPr>
-            <a:r>
-              <a:rPr lang="en-US" sz="1150" dirty="0">
+            <a:endParaRPr lang="en-US" sz="1100" dirty="0"/>
+          </a:p>
+          <a:p>
+            <a:pPr indent="0" marL="0">
+              <a:buNone/>
+            </a:pPr>
+            <a:r>
+              <a:rPr lang="en-US" sz="1100" dirty="0">
                 <a:solidFill>
                   <a:schemeClr val="tx2"/>
                 </a:solidFill>
               </a:rPr>
               <a:t>reports the current through R1 (one branch) instead of the total</a:t>
             </a:r>
-            <a:endParaRPr lang="en-US" sz="1150" dirty="0"/>
+            <a:endParaRPr lang="en-US" sz="1100" dirty="0"/>
           </a:p>
         </p:txBody>
       </p:sp>
@@ -8145,12 +8145,131 @@
         </p:nvSpPr>
         <p:spPr>
           <a:xfrm>
-            <a:off x="5760720" y="4443984"/>
-            <a:ext cx="5852160" cy="896112"/>
+            <a:off x="5760720" y="3895344"/>
+            <a:ext cx="5852160" cy="749808"/>
           </a:xfrm>
           <a:prstGeom prst="roundRect">
             <a:avLst>
-              <a:gd name="adj" fmla="val 8163"/>
+              <a:gd name="adj" fmla="val 9756"/>
+            </a:avLst>
+          </a:prstGeom>
+          <a:solidFill>
+            <a:srgbClr val="F3EFEA"/>
+          </a:solidFill>
+          <a:ln w="12700">
+            <a:solidFill>
+              <a:srgbClr val="FFFFFF"/>
+            </a:solidFill>
+            <a:prstDash val="solid"/>
+          </a:ln>
+        </p:spPr>
+      </p:sp>
+      <p:sp>
+        <p:nvSpPr>
+          <p:cNvPr id="16" name="option 4"/>
+          <p:cNvSpPr txBox="1"/>
+          <p:nvPr/>
+        </p:nvSpPr>
+        <p:spPr>
+          <a:xfrm>
+            <a:off x="5897880" y="3950208"/>
+            <a:ext cx="1371600" cy="640080"/>
+          </a:xfrm>
+          <a:prstGeom prst="rect">
+            <a:avLst/>
+          </a:prstGeom>
+          <a:noFill/>
+          <a:ln/>
+        </p:spPr>
+        <p:txBody>
+          <a:bodyPr wrap="square" lIns="0" tIns="0" rIns="0" bIns="0" rtlCol="0" anchor="ctr"/>
+          <a:lstStyle/>
+          <a:p>
+            <a:pPr indent="0" marL="0">
+              <a:buNone/>
+            </a:pPr>
+            <a:r>
+              <a:rPr lang="en-US" sz="2000" b="1" dirty="0">
+                <a:solidFill>
+                  <a:schemeClr val="tx1"/>
+                </a:solidFill>
+                <a:latin typeface="Courier New" pitchFamily="34" charset="0"/>
+                <a:ea typeface="Courier New" pitchFamily="34" charset="-122"/>
+                <a:cs typeface="Courier New" pitchFamily="34" charset="-120"/>
+              </a:rPr>
+              <a:t>2.40 A</a:t>
+            </a:r>
+            <a:endParaRPr lang="en-US" sz="2000" dirty="0"/>
+          </a:p>
+        </p:txBody>
+      </p:sp>
+      <p:sp>
+        <p:nvSpPr>
+          <p:cNvPr id="17" name="option why 4"/>
+          <p:cNvSpPr txBox="1"/>
+          <p:nvPr/>
+        </p:nvSpPr>
+        <p:spPr>
+          <a:xfrm>
+            <a:off x="7315200" y="3950208"/>
+            <a:ext cx="4206240" cy="640080"/>
+          </a:xfrm>
+          <a:prstGeom prst="rect">
+            <a:avLst/>
+          </a:prstGeom>
+          <a:noFill/>
+          <a:ln/>
+        </p:spPr>
+        <p:txBody>
+          <a:bodyPr wrap="square" lIns="0" tIns="0" rIns="0" bIns="0" rtlCol="0" anchor="ctr"/>
+          <a:lstStyle/>
+          <a:p>
+            <a:pPr indent="0" marL="0">
+              <a:buNone/>
+            </a:pPr>
+            <a:r>
+              <a:rPr lang="en-US" sz="1100" b="1" dirty="0">
+                <a:solidFill>
+                  <a:schemeClr val="tx1"/>
+                </a:solidFill>
+                <a:latin typeface="Courier New" pitchFamily="34" charset="0"/>
+                <a:ea typeface="Courier New" pitchFamily="34" charset="-122"/>
+                <a:cs typeface="Courier New" pitchFamily="34" charset="-120"/>
+              </a:rPr>
+              <a:t>decoy</a:t>
+            </a:r>
+            <a:endParaRPr lang="en-US" sz="1100" dirty="0"/>
+          </a:p>
+          <a:p>
+            <a:pPr indent="0" marL="0">
+              <a:buNone/>
+            </a:pPr>
+            <a:r>
+              <a:rPr lang="en-US" sz="1100" dirty="0">
+                <a:solidFill>
+                  <a:schemeClr val="tx2"/>
+                </a:solidFill>
+              </a:rPr>
+              <a:t>0.9 × the largest option — so the lone large value is not a giveaway by size</a:t>
+            </a:r>
+            <a:endParaRPr lang="en-US" sz="1100" dirty="0"/>
+          </a:p>
+        </p:txBody>
+      </p:sp>
+      <p:sp>
+        <p:nvSpPr>
+          <p:cNvPr id="18" name="option card 5"/>
+          <p:cNvSpPr/>
+          <p:nvPr/>
+        </p:nvSpPr>
+        <p:spPr>
+          <a:xfrm>
+            <a:off x="5760720" y="4736592"/>
+            <a:ext cx="5852160" cy="749808"/>
+          </a:xfrm>
+          <a:prstGeom prst="roundRect">
+            <a:avLst>
+              <a:gd name="adj" fmla="val 9756"/>
             </a:avLst>
           </a:prstGeom>
           <a:solidFill>
@@ -8166,14 +8285,14 @@
       </p:sp>
       <p:sp>
         <p:nvSpPr>
-          <p:cNvPr id="16" name="option 4"/>
-          <p:cNvSpPr txBox="1"/>
-          <p:nvPr/>
-        </p:nvSpPr>
-        <p:spPr>
-          <a:xfrm>
-            <a:off x="5897880" y="4517136"/>
-            <a:ext cx="1371600" cy="749808"/>
+          <p:cNvPr id="19" name="option 5"/>
+          <p:cNvSpPr txBox="1"/>
+          <p:nvPr/>
+        </p:nvSpPr>
+        <p:spPr>
+          <a:xfrm>
+            <a:off x="5897880" y="4791456"/>
+            <a:ext cx="1371600" cy="640080"/>
           </a:xfrm>
           <a:prstGeom prst="rect">
             <a:avLst/>
@@ -8189,7 +8308,7 @@
               <a:buNone/>
             </a:pPr>
             <a:r>
-              <a:rPr lang="en-US" sz="2200" b="1" dirty="0">
+              <a:rPr lang="en-US" sz="2000" b="1" dirty="0">
                 <a:solidFill>
                   <a:schemeClr val="accent1"/>
                 </a:solidFill>
@@ -8199,20 +8318,20 @@
               </a:rPr>
               <a:t>2.00 A</a:t>
             </a:r>
-            <a:endParaRPr lang="en-US" sz="2200" dirty="0"/>
-          </a:p>
-        </p:txBody>
-      </p:sp>
-      <p:sp>
-        <p:nvSpPr>
-          <p:cNvPr id="17" name="option why 4"/>
-          <p:cNvSpPr txBox="1"/>
-          <p:nvPr/>
-        </p:nvSpPr>
-        <p:spPr>
-          <a:xfrm>
-            <a:off x="7315200" y="4517136"/>
-            <a:ext cx="4206240" cy="749808"/>
+            <a:endParaRPr lang="en-US" sz="2000" dirty="0"/>
+          </a:p>
+        </p:txBody>
+      </p:sp>
+      <p:sp>
+        <p:nvSpPr>
+          <p:cNvPr id="20" name="option why 5"/>
+          <p:cNvSpPr txBox="1"/>
+          <p:nvPr/>
+        </p:nvSpPr>
+        <p:spPr>
+          <a:xfrm>
+            <a:off x="7315200" y="4791456"/>
+            <a:ext cx="4206240" cy="640080"/>
           </a:xfrm>
           <a:prstGeom prst="rect">
             <a:avLst/>
@@ -8228,7 +8347,7 @@
               <a:buNone/>
             </a:pPr>
             <a:r>
-              <a:rPr lang="en-US" sz="1150" b="1" dirty="0">
+              <a:rPr lang="en-US" sz="1100" b="1" dirty="0">
                 <a:solidFill>
                   <a:schemeClr val="tx1"/>
                 </a:solidFill>
@@ -8238,27 +8357,27 @@
               </a:rPr>
               <a:t>correct</a:t>
             </a:r>
-            <a:endParaRPr lang="en-US" sz="1150" dirty="0"/>
-          </a:p>
-          <a:p>
-            <a:pPr indent="0" marL="0">
-              <a:buNone/>
-            </a:pPr>
-            <a:r>
-              <a:rPr lang="en-US" sz="1150" dirty="0">
+            <a:endParaRPr lang="en-US" sz="1100" dirty="0"/>
+          </a:p>
+          <a:p>
+            <a:pPr indent="0" marL="0">
+              <a:buNone/>
+            </a:pPr>
+            <a:r>
+              <a:rPr lang="en-US" sz="1100" dirty="0">
                 <a:solidFill>
                   <a:schemeClr val="tx2"/>
                 </a:solidFill>
               </a:rPr>
               <a:t>3 ‖ 6 = 2 Ω, + 4 = 6 Ω, 12 V / 6 Ω</a:t>
             </a:r>
-            <a:endParaRPr lang="en-US" sz="1150" dirty="0"/>
-          </a:p>
-        </p:txBody>
-      </p:sp>
-      <p:sp>
-        <p:nvSpPr>
-          <p:cNvPr id="18" name="fallback note"/>
+            <a:endParaRPr lang="en-US" sz="1100" dirty="0"/>
+          </a:p>
+        </p:txBody>
+      </p:sp>
+      <p:sp>
+        <p:nvSpPr>
+          <p:cNvPr id="21" name="fallback note"/>
           <p:cNvSpPr txBox="1"/>
           <p:nvPr/>
         </p:nvSpPr>
@@ -10567,7 +10686,7 @@
                 <a:ea typeface="Courier New" pitchFamily="34" charset="-122"/>
                 <a:cs typeface="Courier New" pitchFamily="34" charset="-120"/>
               </a:rPr>
-              <a:t>bank_id: PHY2-DC-SPRTC3-10232026</a:t>
+              <a:t>bank_id: PHY2-DC-SPRTC3-10292026</a:t>
             </a:r>
             <a:endParaRPr lang="en-US" sz="1100" dirty="0"/>
           </a:p>
@@ -10618,7 +10737,7 @@
                 <a:ea typeface="Courier New" pitchFamily="34" charset="-122"/>
                 <a:cs typeface="Courier New" pitchFamily="34" charset="-120"/>
               </a:rPr>
-              <a:t>min_resistors: 4     max_resistors: 6</a:t>
+              <a:t>min_resistors: 5     max_resistors: 6</a:t>
             </a:r>
             <a:endParaRPr lang="en-US" sz="1100" dirty="0"/>
           </a:p>

</xml_diff>